<commit_message>
Ship pitch deck v2 and replace Grok/xAI wording with AI
Update the public pitch slides, notes, and downloadable deck, and make the marketing site speak generically about AI instead of naming Grok or xAI.

Co-authored-by: eriq breland <eriqbre@gmail.com>
</commit_message>
<xml_diff>
--- a/pitch/voxa-pitch.pptx
+++ b/pitch/voxa-pitch.pptx
@@ -511,7 +511,7 @@
           <a:p>
             <a:r>
               <a:rPr lang="en-US" dirty="0"/>
-              <a:t>Voxa is a voice-first AI assistant for real estate agents, on iPhone and iPad, powered by Grok: you just say it.
+              <a:t>Voxa is a voice-first AI assistant for real estate agents, on iPhone and iPad, powered by AI: you just say it.
 Sources: eriqbre/voxa-spec PR #232 (iPhone + iPad app). Screen: Simulator, Trusted friend conversation opening.</a:t>
             </a:r>
             <a:endParaRPr lang="en-US" dirty="0"/>
@@ -689,7 +689,7 @@
           <a:p>
             <a:r>
               <a:rPr lang="en-US" dirty="0"/>
-              <a:t>Most of an agent's week isn't selling: it's posts, open house prep, replies, feedback and follow-ups scattered across texts, email, calendar and social.</a:t>
+              <a:t>Most of an agent's week isn't selling; it's building and sticking to a marketing plan, daily posts, open house prep, replies and follow-ups scattered across texts, email, calendar and social.</a:t>
             </a:r>
             <a:endParaRPr lang="en-US" dirty="0"/>
           </a:p>
@@ -777,7 +777,7 @@
           <a:p>
             <a:r>
               <a:rPr lang="en-US" dirty="0"/>
-              <a:t>Voxa pulls out only what needs you today. Grok drafts; you decide. Nothing sends or posts without your tap.
+              <a:t>Voxa pulls out only what needs you today. Voxa drafts; you decide. Nothing sends or posts without your tap.
 The cards on the left are an illustration, not a screenshot. Sources: eriqbre/voxa-spec PRs #244/#245 (never posts on its own), #319 (staged events and reminders).</a:t>
             </a:r>
             <a:endParaRPr lang="en-US" dirty="0"/>
@@ -1044,7 +1044,7 @@
           <a:p>
             <a:r>
               <a:rPr lang="en-US" dirty="0"/>
-              <a:t>Ask about your inbox by voice. Grok tags each email to the listing it belongs to and summarizes documents, like contract highlights. Summaries are not legal advice.
+              <a:t>Ask about your inbox by voice. Voxa tags each email to the listing it belongs to and summarizes documents, like contract highlights. Summaries are not legal advice.
 Sources: eriqbre/voxa-spec PRs #316/#321 (mail tagging, document summaries).</a:t>
             </a:r>
             <a:endParaRPr lang="en-US" dirty="0"/>
@@ -1310,7 +1310,7 @@
           <a:p>
             <a:r>
               <a:rPr lang="en-US" dirty="0"/>
-              <a:t>Three steps: you speak, Grok does the work, you approve. What you say is sent to xAI so Grok can reply.</a:t>
+              <a:t>Three steps: you speak, Voxa does the work, you approve. What you say is sent to our AI provider so it can reply.</a:t>
             </a:r>
             <a:endParaRPr lang="en-US" dirty="0"/>
           </a:p>
@@ -2042,7 +2042,7 @@
                 <a:ea typeface="Manrope" pitchFamily="34" charset="-122"/>
                 <a:cs typeface="Manrope" pitchFamily="34" charset="-120"/>
               </a:rPr>
-              <a:t>Powered by Grok</a:t>
+              <a:t>Powered by AI</a:t>
             </a:r>
             <a:endParaRPr lang="en-US" sz="1400" dirty="0"/>
           </a:p>
@@ -2871,7 +2871,7 @@
                 <a:ea typeface="Manrope" pitchFamily="34" charset="-122"/>
                 <a:cs typeface="Manrope" pitchFamily="34" charset="-120"/>
               </a:rPr>
-              <a:t>Daily posts</a:t>
+              <a:t>Building and sticking to a marketing plan</a:t>
             </a:r>
             <a:endParaRPr lang="en-US" sz="1650" dirty="0"/>
           </a:p>
@@ -2910,7 +2910,7 @@
                 <a:ea typeface="Manrope" pitchFamily="34" charset="-122"/>
                 <a:cs typeface="Manrope" pitchFamily="34" charset="-120"/>
               </a:rPr>
-              <a:t>Social</a:t>
+              <a:t>Plan + social</a:t>
             </a:r>
             <a:endParaRPr lang="en-US" sz="1250" dirty="0"/>
           </a:p>
@@ -3044,7 +3044,7 @@
                 <a:ea typeface="Manrope" pitchFamily="34" charset="-122"/>
                 <a:cs typeface="Manrope" pitchFamily="34" charset="-120"/>
               </a:rPr>
-              <a:t>Open house prep and follow-up</a:t>
+              <a:t>Daily posts</a:t>
             </a:r>
             <a:endParaRPr lang="en-US" sz="1650" dirty="0"/>
           </a:p>
@@ -3083,7 +3083,7 @@
                 <a:ea typeface="Manrope" pitchFamily="34" charset="-122"/>
                 <a:cs typeface="Manrope" pitchFamily="34" charset="-120"/>
               </a:rPr>
-              <a:t>Calendar + texts</a:t>
+              <a:t>Social</a:t>
             </a:r>
             <a:endParaRPr lang="en-US" sz="1250" dirty="0"/>
           </a:p>
@@ -3217,7 +3217,7 @@
                 <a:ea typeface="Manrope" pitchFamily="34" charset="-122"/>
                 <a:cs typeface="Manrope" pitchFamily="34" charset="-120"/>
               </a:rPr>
-              <a:t>Email replies</a:t>
+              <a:t>Open house prep and follow-up</a:t>
             </a:r>
             <a:endParaRPr lang="en-US" sz="1650" dirty="0"/>
           </a:p>
@@ -3256,7 +3256,7 @@
                 <a:ea typeface="Manrope" pitchFamily="34" charset="-122"/>
                 <a:cs typeface="Manrope" pitchFamily="34" charset="-120"/>
               </a:rPr>
-              <a:t>Email</a:t>
+              <a:t>Calendar + texts</a:t>
             </a:r>
             <a:endParaRPr lang="en-US" sz="1250" dirty="0"/>
           </a:p>
@@ -3390,7 +3390,7 @@
                 <a:ea typeface="Manrope" pitchFamily="34" charset="-122"/>
                 <a:cs typeface="Manrope" pitchFamily="34" charset="-120"/>
               </a:rPr>
-              <a:t>Showing feedback</a:t>
+              <a:t>Email replies</a:t>
             </a:r>
             <a:endParaRPr lang="en-US" sz="1650" dirty="0"/>
           </a:p>
@@ -3429,7 +3429,7 @@
                 <a:ea typeface="Manrope" pitchFamily="34" charset="-122"/>
                 <a:cs typeface="Manrope" pitchFamily="34" charset="-120"/>
               </a:rPr>
-              <a:t>Texts + email</a:t>
+              <a:t>Email</a:t>
             </a:r>
             <a:endParaRPr lang="en-US" sz="1250" dirty="0"/>
           </a:p>
@@ -3904,7 +3904,7 @@
                 <a:ea typeface="Manrope" pitchFamily="34" charset="-122"/>
                 <a:cs typeface="Manrope" pitchFamily="34" charset="-120"/>
               </a:rPr>
-              <a:t>Grok drafted it in your voice.</a:t>
+              <a:t>Voxa drafted it in your voice.</a:t>
             </a:r>
             <a:endParaRPr lang="en-US" sz="1300" dirty="0"/>
           </a:p>
@@ -4418,7 +4418,7 @@
                 <a:ea typeface="Fraunces" pitchFamily="34" charset="-122"/>
                 <a:cs typeface="Fraunces" pitchFamily="34" charset="-120"/>
               </a:rPr>
-              <a:t>Grok drafts. You decide.</a:t>
+              <a:t>Voxa drafts. You decide.</a:t>
             </a:r>
             <a:endParaRPr lang="en-US" sz="2800" dirty="0"/>
           </a:p>
@@ -6761,7 +6761,7 @@
                 <a:ea typeface="Manrope" pitchFamily="34" charset="-122"/>
                 <a:cs typeface="Manrope" pitchFamily="34" charset="-120"/>
               </a:rPr>
-              <a:t>Ask what came in. Grok sorts it out.</a:t>
+              <a:t>Ask what came in. Voxa sorts it out.</a:t>
             </a:r>
             <a:endParaRPr lang="en-US" sz="1900" dirty="0"/>
           </a:p>
@@ -6932,7 +6932,7 @@
                 <a:ea typeface="Manrope" pitchFamily="34" charset="-122"/>
                 <a:cs typeface="Manrope" pitchFamily="34" charset="-120"/>
               </a:rPr>
-              <a:t>Grok tags each email to the listing it belongs to.</a:t>
+              <a:t>Voxa tags each email to the listing it belongs to.</a:t>
             </a:r>
             <a:endParaRPr lang="en-US" sz="1500" dirty="0"/>
           </a:p>
@@ -9084,7 +9084,7 @@
                 <a:ea typeface="Fraunces" pitchFamily="34" charset="-122"/>
                 <a:cs typeface="Fraunces" pitchFamily="34" charset="-120"/>
               </a:rPr>
-              <a:t>Speak. Grok works. You approve.</a:t>
+              <a:t>Speak. Voxa works. You approve.</a:t>
             </a:r>
             <a:endParaRPr lang="en-US" sz="4200" dirty="0"/>
           </a:p>
@@ -9353,7 +9353,7 @@
                 <a:ea typeface="Fraunces" pitchFamily="34" charset="-122"/>
                 <a:cs typeface="Fraunces" pitchFamily="34" charset="-120"/>
               </a:rPr>
-              <a:t>Grok works</a:t>
+              <a:t>Voxa works</a:t>
             </a:r>
             <a:endParaRPr lang="en-US" sz="2800" dirty="0"/>
           </a:p>
@@ -9595,7 +9595,7 @@
                 <a:ea typeface="Manrope" pitchFamily="34" charset="-122"/>
                 <a:cs typeface="Manrope" pitchFamily="34" charset="-120"/>
               </a:rPr>
-              <a:t>What you say is sent to xAI so Grok can reply.</a:t>
+              <a:t>What you say is sent to our AI provider so it can reply.</a:t>
             </a:r>
             <a:endParaRPr lang="en-US" sz="1300" dirty="0"/>
           </a:p>

</xml_diff>

<commit_message>
Add Demo 5 video to slide 04 and mark it a design preview
Re-encode the v4 You talk slide, ship videos/demo-5.mp4 plus its poster, and leave demos 1–4 as placeholders.

Co-authored-by: eriq breland <eriqbre@gmail.com>
</commit_message>
<xml_diff>
--- a/pitch/voxa-pitch.pptx
+++ b/pitch/voxa-pitch.pptx
@@ -955,7 +955,7 @@
           <a:p>
             <a:r>
               <a:rPr lang="en-US" dirty="0"/>
-              <a:t>You don’t need perfect words. Talk the way you normally do, ums and all, and Voxa works out what you mean. It checks your calendar before booking: Friday at 2 clashes with a showing, so it offers noon or anytime Saturday. Pick noon and it fills in an event card, Lunch with client, Fri 12:00 PM, with an Add to calendar button for you to tap.</a:t>
+              <a:t>Design preview, not shipped yet; prototype screens with example data. You don’t need perfect words. Talk the way you normally do, ums and all, and Voxa works out what you mean. It checks your calendar before booking: Friday at 2 clashes with a showing, so it offers noon or anytime Saturday. Pick noon and it fills in an event card, Lunch with client, Fri 12:00 PM, with an Add to calendar button for you to tap.</a:t>
             </a:r>
             <a:endParaRPr lang="en-US" dirty="0"/>
           </a:p>
@@ -5688,38 +5688,65 @@
       </p:sp>
       <p:sp>
         <p:nvSpPr>
-          <p:cNvPr id="12" name="Text 9"/>
-          <p:cNvSpPr/>
-          <p:nvPr/>
-        </p:nvSpPr>
-        <p:spPr>
-          <a:xfrm>
-            <a:off x="4206240" y="1051560"/>
-            <a:ext cx="4572000" cy="274320"/>
-          </a:xfrm>
-          <a:prstGeom prst="rect">
-            <a:avLst/>
-          </a:prstGeom>
-          <a:noFill/>
-          <a:ln/>
-        </p:spPr>
-        <p:txBody>
-          <a:bodyPr wrap="square" lIns="0" tIns="0" rIns="0" bIns="0" rtlCol="0" anchor="t"/>
-          <a:lstStyle/>
-          <a:p>
-            <a:pPr indent="0" marL="0">
-              <a:buNone/>
-            </a:pPr>
-            <a:r>
-              <a:rPr lang="en-US" sz="1200" b="1" spc="250" kern="0" dirty="0">
-                <a:solidFill>
-                  <a:srgbClr val="1D9A84"/>
-                </a:solidFill>
-                <a:latin typeface="Manrope" pitchFamily="34" charset="0"/>
-                <a:ea typeface="Manrope" pitchFamily="34" charset="-122"/>
-                <a:cs typeface="Manrope" pitchFamily="34" charset="-120"/>
-              </a:rPr>
-              <a:t>JUST TALK</a:t>
+          <p:cNvPr id="12" name="Shape 9"/>
+          <p:cNvSpPr/>
+          <p:nvPr/>
+        </p:nvSpPr>
+        <p:spPr>
+          <a:xfrm>
+            <a:off x="4206240" y="896112"/>
+            <a:ext cx="2514600" cy="384048"/>
+          </a:xfrm>
+          <a:prstGeom prst="roundRect">
+            <a:avLst>
+              <a:gd name="adj" fmla="val 50000"/>
+            </a:avLst>
+          </a:prstGeom>
+          <a:solidFill>
+            <a:srgbClr val="FFF3D6"/>
+          </a:solidFill>
+          <a:ln w="12700">
+            <a:solidFill>
+              <a:srgbClr val="C9A227"/>
+            </a:solidFill>
+            <a:prstDash val="solid"/>
+          </a:ln>
+        </p:spPr>
+      </p:sp>
+      <p:sp>
+        <p:nvSpPr>
+          <p:cNvPr id="13" name="Text 10"/>
+          <p:cNvSpPr/>
+          <p:nvPr/>
+        </p:nvSpPr>
+        <p:spPr>
+          <a:xfrm>
+            <a:off x="4206240" y="896112"/>
+            <a:ext cx="2514600" cy="384048"/>
+          </a:xfrm>
+          <a:prstGeom prst="rect">
+            <a:avLst/>
+          </a:prstGeom>
+          <a:noFill/>
+          <a:ln/>
+        </p:spPr>
+        <p:txBody>
+          <a:bodyPr wrap="square" lIns="0" tIns="0" rIns="0" bIns="0" rtlCol="0" anchor="ctr"/>
+          <a:lstStyle/>
+          <a:p>
+            <a:pPr algn="ctr" indent="0" marL="0">
+              <a:buNone/>
+            </a:pPr>
+            <a:r>
+              <a:rPr lang="en-US" sz="1200" b="1" spc="200" kern="0" dirty="0">
+                <a:solidFill>
+                  <a:srgbClr val="7A5B00"/>
+                </a:solidFill>
+                <a:latin typeface="Manrope" pitchFamily="34" charset="0"/>
+                <a:ea typeface="Manrope" pitchFamily="34" charset="-122"/>
+                <a:cs typeface="Manrope" pitchFamily="34" charset="-120"/>
+              </a:rPr>
+              <a:t>DESIGN PREVIEW</a:t>
             </a:r>
             <a:endParaRPr lang="en-US" sz="1200" dirty="0"/>
           </a:p>
@@ -5727,7 +5754,7 @@
       </p:sp>
       <p:sp>
         <p:nvSpPr>
-          <p:cNvPr id="13" name="Text 10"/>
+          <p:cNvPr id="14" name="Text 11"/>
           <p:cNvSpPr/>
           <p:nvPr/>
         </p:nvSpPr>
@@ -5766,7 +5793,7 @@
       </p:sp>
       <p:sp>
         <p:nvSpPr>
-          <p:cNvPr id="14" name="Text 11"/>
+          <p:cNvPr id="15" name="Text 12"/>
           <p:cNvSpPr/>
           <p:nvPr/>
         </p:nvSpPr>
@@ -5808,7 +5835,7 @@
       </p:sp>
       <p:sp>
         <p:nvSpPr>
-          <p:cNvPr id="15" name="Shape 12"/>
+          <p:cNvPr id="16" name="Shape 13"/>
           <p:cNvSpPr/>
           <p:nvPr/>
         </p:nvSpPr>
@@ -5835,7 +5862,7 @@
       </p:sp>
       <p:sp>
         <p:nvSpPr>
-          <p:cNvPr id="16" name="Text 13"/>
+          <p:cNvPr id="17" name="Text 14"/>
           <p:cNvSpPr/>
           <p:nvPr/>
         </p:nvSpPr>
@@ -5877,7 +5904,7 @@
       </p:sp>
       <p:sp>
         <p:nvSpPr>
-          <p:cNvPr id="17" name="Shape 14"/>
+          <p:cNvPr id="18" name="Shape 15"/>
           <p:cNvSpPr/>
           <p:nvPr/>
         </p:nvSpPr>
@@ -5899,7 +5926,7 @@
       </p:sp>
       <p:sp>
         <p:nvSpPr>
-          <p:cNvPr id="18" name="Text 15"/>
+          <p:cNvPr id="19" name="Text 16"/>
           <p:cNvSpPr/>
           <p:nvPr/>
         </p:nvSpPr>
@@ -5938,7 +5965,7 @@
       </p:sp>
       <p:sp>
         <p:nvSpPr>
-          <p:cNvPr id="19" name="Shape 16"/>
+          <p:cNvPr id="20" name="Shape 17"/>
           <p:cNvSpPr/>
           <p:nvPr/>
         </p:nvSpPr>
@@ -5967,7 +5994,7 @@
       </p:sp>
       <p:sp>
         <p:nvSpPr>
-          <p:cNvPr id="20" name="Shape 17"/>
+          <p:cNvPr id="21" name="Shape 18"/>
           <p:cNvSpPr/>
           <p:nvPr/>
         </p:nvSpPr>
@@ -5989,7 +6016,7 @@
       </p:sp>
       <p:sp>
         <p:nvSpPr>
-          <p:cNvPr id="21" name="Shape 18"/>
+          <p:cNvPr id="22" name="Shape 19"/>
           <p:cNvSpPr/>
           <p:nvPr/>
         </p:nvSpPr>
@@ -6014,7 +6041,7 @@
       </p:sp>
       <p:sp>
         <p:nvSpPr>
-          <p:cNvPr id="22" name="Shape 19"/>
+          <p:cNvPr id="23" name="Shape 20"/>
           <p:cNvSpPr/>
           <p:nvPr/>
         </p:nvSpPr>
@@ -6034,7 +6061,7 @@
       </p:sp>
       <p:sp>
         <p:nvSpPr>
-          <p:cNvPr id="23" name="Text 20"/>
+          <p:cNvPr id="24" name="Text 21"/>
           <p:cNvSpPr/>
           <p:nvPr/>
         </p:nvSpPr>
@@ -6073,7 +6100,7 @@
       </p:sp>
       <p:sp>
         <p:nvSpPr>
-          <p:cNvPr id="24" name="Shape 21"/>
+          <p:cNvPr id="25" name="Shape 22"/>
           <p:cNvSpPr/>
           <p:nvPr/>
         </p:nvSpPr>
@@ -6100,7 +6127,7 @@
       </p:sp>
       <p:sp>
         <p:nvSpPr>
-          <p:cNvPr id="25" name="Text 22"/>
+          <p:cNvPr id="26" name="Text 23"/>
           <p:cNvSpPr/>
           <p:nvPr/>
         </p:nvSpPr>
@@ -6139,7 +6166,7 @@
       </p:sp>
       <p:sp>
         <p:nvSpPr>
-          <p:cNvPr id="26" name="Text 23"/>
+          <p:cNvPr id="27" name="Text 24"/>
           <p:cNvSpPr/>
           <p:nvPr/>
         </p:nvSpPr>

</xml_diff>

<commit_message>
Replace Demo 5 and slide 04 with v5, cache-bust the assets
Ship the updated You talk slide, video, and poster, and append ?v=5 so GitHub Pages does not keep serving the v4 files.

Co-authored-by: eriq breland <eriqbre@gmail.com>
</commit_message>
<xml_diff>
--- a/pitch/voxa-pitch.pptx
+++ b/pitch/voxa-pitch.pptx
@@ -955,7 +955,7 @@
           <a:p>
             <a:r>
               <a:rPr lang="en-US" dirty="0"/>
-              <a:t>Design preview, not shipped yet; prototype screens with example data. You don’t need perfect words. Talk the way you normally do, ums and all, and Voxa works out what you mean. It checks your calendar before booking: Friday at 2 clashes with a showing, so it offers noon or anytime Saturday. Pick noon and it fills in an event card, Lunch with client, Fri 12:00 PM, with an Add to calendar button for you to tap.</a:t>
+              <a:t>Design preview, not shipped yet; prototype screens with example data. You don’t need perfect words. Talk the way you normally do, ums and all, and Voxa works out what you mean. It checks your calendar before booking: Friday at 2 clashes with a showing, so it offers noon or anytime Saturday. Pick noon and it fills in an event card: Lunch with client, Friday the 23rd at 12:00 PM, marked Free, no conflicts, with an Add to calendar button for you to tap.</a:t>
             </a:r>
             <a:endParaRPr lang="en-US" dirty="0"/>
           </a:p>
@@ -5841,12 +5841,12 @@
         </p:nvSpPr>
         <p:spPr>
           <a:xfrm>
-            <a:off x="5257800" y="2926080"/>
-            <a:ext cx="6217920" cy="868680"/>
+            <a:off x="4526280" y="2926080"/>
+            <a:ext cx="3383280" cy="1097280"/>
           </a:xfrm>
           <a:prstGeom prst="roundRect">
             <a:avLst>
-              <a:gd name="adj" fmla="val 23158"/>
+              <a:gd name="adj" fmla="val 18333"/>
             </a:avLst>
           </a:prstGeom>
           <a:solidFill>
@@ -5868,8 +5868,8 @@
         </p:nvSpPr>
         <p:spPr>
           <a:xfrm>
-            <a:off x="5532120" y="2926080"/>
-            <a:ext cx="5669280" cy="868680"/>
+            <a:off x="4754880" y="2926080"/>
+            <a:ext cx="2926080" cy="1097280"/>
           </a:xfrm>
           <a:prstGeom prst="rect">
             <a:avLst/>
@@ -5888,7 +5888,7 @@
               <a:buNone/>
             </a:pPr>
             <a:r>
-              <a:rPr lang="en-US" sz="1550" i="1" dirty="0">
+              <a:rPr lang="en-US" sz="1500" i="1" dirty="0">
                 <a:solidFill>
                   <a:srgbClr val="10201C"/>
                 </a:solidFill>
@@ -5898,7 +5898,7 @@
               </a:rPr>
               <a:t>“Um, can you, uh… put lunch with a client on my, uh, calendar for Friday at, um, 2?”</a:t>
             </a:r>
-            <a:endParaRPr lang="en-US" sz="1550" dirty="0"/>
+            <a:endParaRPr lang="en-US" sz="1500" dirty="0"/>
           </a:p>
         </p:txBody>
       </p:sp>
@@ -5910,12 +5910,12 @@
         </p:nvSpPr>
         <p:spPr>
           <a:xfrm>
-            <a:off x="4206240" y="3931920"/>
-            <a:ext cx="6217920" cy="658368"/>
+            <a:off x="4206240" y="4160520"/>
+            <a:ext cx="3383280" cy="868680"/>
           </a:xfrm>
           <a:prstGeom prst="roundRect">
             <a:avLst>
-              <a:gd name="adj" fmla="val 30556"/>
+              <a:gd name="adj" fmla="val 23158"/>
             </a:avLst>
           </a:prstGeom>
           <a:solidFill>
@@ -5932,8 +5932,8 @@
         </p:nvSpPr>
         <p:spPr>
           <a:xfrm>
-            <a:off x="4480560" y="3931920"/>
-            <a:ext cx="5669280" cy="658368"/>
+            <a:off x="4434840" y="4160520"/>
+            <a:ext cx="2926080" cy="868680"/>
           </a:xfrm>
           <a:prstGeom prst="rect">
             <a:avLst/>
@@ -5946,10 +5946,13 @@
           <a:lstStyle/>
           <a:p>
             <a:pPr indent="0" marL="0">
-              <a:buNone/>
-            </a:pPr>
-            <a:r>
-              <a:rPr lang="en-US" sz="1550" b="1" dirty="0">
+              <a:lnSpc>
+                <a:spcPct val="110000"/>
+              </a:lnSpc>
+              <a:buNone/>
+            </a:pPr>
+            <a:r>
+              <a:rPr lang="en-US" sz="1500" b="1" dirty="0">
                 <a:solidFill>
                   <a:srgbClr val="FFFFFF"/>
                 </a:solidFill>
@@ -5959,7 +5962,7 @@
               </a:rPr>
               <a:t>“You have a showing then. You’re free at noon, or anytime Saturday.”</a:t>
             </a:r>
-            <a:endParaRPr lang="en-US" sz="1550" dirty="0"/>
+            <a:endParaRPr lang="en-US" sz="1500" dirty="0"/>
           </a:p>
         </p:txBody>
       </p:sp>
@@ -5971,22 +5974,88 @@
         </p:nvSpPr>
         <p:spPr>
           <a:xfrm>
-            <a:off x="4206240" y="4773168"/>
-            <a:ext cx="7269480" cy="804672"/>
+            <a:off x="6309360" y="5166360"/>
+            <a:ext cx="1600200" cy="457200"/>
           </a:xfrm>
           <a:prstGeom prst="roundRect">
             <a:avLst>
-              <a:gd name="adj" fmla="val 25000"/>
+              <a:gd name="adj" fmla="val 44000"/>
             </a:avLst>
           </a:prstGeom>
           <a:solidFill>
             <a:srgbClr val="FFFFFF"/>
           </a:solidFill>
+          <a:ln w="9525">
+            <a:solidFill>
+              <a:srgbClr val="DBE6E2"/>
+            </a:solidFill>
+            <a:prstDash val="solid"/>
+          </a:ln>
+        </p:spPr>
+      </p:sp>
+      <p:sp>
+        <p:nvSpPr>
+          <p:cNvPr id="21" name="Text 18"/>
+          <p:cNvSpPr/>
+          <p:nvPr/>
+        </p:nvSpPr>
+        <p:spPr>
+          <a:xfrm>
+            <a:off x="6309360" y="5166360"/>
+            <a:ext cx="1600200" cy="457200"/>
+          </a:xfrm>
+          <a:prstGeom prst="rect">
+            <a:avLst/>
+          </a:prstGeom>
+          <a:noFill/>
+          <a:ln/>
+        </p:spPr>
+        <p:txBody>
+          <a:bodyPr wrap="square" lIns="0" tIns="0" rIns="0" bIns="0" rtlCol="0" anchor="ctr"/>
+          <a:lstStyle/>
+          <a:p>
+            <a:pPr algn="ctr" indent="0" marL="0">
+              <a:buNone/>
+            </a:pPr>
+            <a:r>
+              <a:rPr lang="en-US" sz="1500" i="1" dirty="0">
+                <a:solidFill>
+                  <a:srgbClr val="10201C"/>
+                </a:solidFill>
+                <a:latin typeface="Manrope" pitchFamily="34" charset="0"/>
+                <a:ea typeface="Manrope" pitchFamily="34" charset="-122"/>
+                <a:cs typeface="Manrope" pitchFamily="34" charset="-120"/>
+              </a:rPr>
+              <a:t>“Noon works.”</a:t>
+            </a:r>
+            <a:endParaRPr lang="en-US" sz="1500" dirty="0"/>
+          </a:p>
+        </p:txBody>
+      </p:sp>
+      <p:sp>
+        <p:nvSpPr>
+          <p:cNvPr id="22" name="Shape 19"/>
+          <p:cNvSpPr/>
+          <p:nvPr/>
+        </p:nvSpPr>
+        <p:spPr>
+          <a:xfrm>
+            <a:off x="8183880" y="2926080"/>
+            <a:ext cx="3291840" cy="2697480"/>
+          </a:xfrm>
+          <a:prstGeom prst="roundRect">
+            <a:avLst>
+              <a:gd name="adj" fmla="val 3766"/>
+            </a:avLst>
+          </a:prstGeom>
+          <a:solidFill>
+            <a:srgbClr val="0E5A52"/>
+          </a:solidFill>
           <a:ln/>
           <a:effectLst>
-            <a:outerShdw sx="100000" sy="100000" kx="0" ky="0" algn="bl" rotWithShape="0" blurRad="304800" dist="50800" dir="5400000">
-              <a:srgbClr val="0F5A4F">
-                <a:alpha val="10000"/>
+            <a:outerShdw sx="100000" sy="100000" kx="0" ky="0" algn="bl" rotWithShape="0" blurRad="228600" dist="63500" dir="5400000">
+              <a:srgbClr val="0E3A34">
+                <a:alpha val="16000"/>
               </a:srgbClr>
             </a:outerShdw>
           </a:effectLst>
@@ -5994,18 +6063,40 @@
       </p:sp>
       <p:sp>
         <p:nvSpPr>
-          <p:cNvPr id="21" name="Shape 18"/>
-          <p:cNvSpPr/>
-          <p:nvPr/>
-        </p:nvSpPr>
-        <p:spPr>
-          <a:xfrm>
-            <a:off x="4407408" y="4937760"/>
-            <a:ext cx="475488" cy="475488"/>
+          <p:cNvPr id="23" name="Shape 20"/>
+          <p:cNvSpPr/>
+          <p:nvPr/>
+        </p:nvSpPr>
+        <p:spPr>
+          <a:xfrm>
+            <a:off x="8234172" y="2926080"/>
+            <a:ext cx="3241548" cy="2697480"/>
           </a:xfrm>
           <a:prstGeom prst="roundRect">
             <a:avLst>
-              <a:gd name="adj" fmla="val 26923"/>
+              <a:gd name="adj" fmla="val 3766"/>
+            </a:avLst>
+          </a:prstGeom>
+          <a:solidFill>
+            <a:srgbClr val="F5FAF9"/>
+          </a:solidFill>
+          <a:ln/>
+        </p:spPr>
+      </p:sp>
+      <p:sp>
+        <p:nvSpPr>
+          <p:cNvPr id="24" name="Shape 21"/>
+          <p:cNvSpPr/>
+          <p:nvPr/>
+        </p:nvSpPr>
+        <p:spPr>
+          <a:xfrm>
+            <a:off x="8476488" y="3200400"/>
+            <a:ext cx="749808" cy="841248"/>
+          </a:xfrm>
+          <a:prstGeom prst="roundRect">
+            <a:avLst>
+              <a:gd name="adj" fmla="val 14634"/>
             </a:avLst>
           </a:prstGeom>
           <a:solidFill>
@@ -6016,59 +6107,92 @@
       </p:sp>
       <p:sp>
         <p:nvSpPr>
-          <p:cNvPr id="22" name="Shape 19"/>
-          <p:cNvSpPr/>
-          <p:nvPr/>
-        </p:nvSpPr>
-        <p:spPr>
-          <a:xfrm>
-            <a:off x="4517136" y="5047488"/>
-            <a:ext cx="256032" cy="237744"/>
-          </a:xfrm>
-          <a:prstGeom prst="rect">
-            <a:avLst/>
-          </a:prstGeom>
-          <a:solidFill>
-            <a:srgbClr val="FFFFFF"/>
-          </a:solidFill>
-          <a:ln w="19050">
-            <a:solidFill>
-              <a:srgbClr val="0F5A4F"/>
-            </a:solidFill>
-            <a:prstDash val="solid"/>
-          </a:ln>
-        </p:spPr>
-      </p:sp>
-      <p:sp>
-        <p:nvSpPr>
-          <p:cNvPr id="23" name="Shape 20"/>
-          <p:cNvSpPr/>
-          <p:nvPr/>
-        </p:nvSpPr>
-        <p:spPr>
-          <a:xfrm>
-            <a:off x="4517136" y="5047488"/>
-            <a:ext cx="256032" cy="73152"/>
-          </a:xfrm>
-          <a:prstGeom prst="rect">
-            <a:avLst/>
-          </a:prstGeom>
-          <a:solidFill>
-            <a:srgbClr val="0F5A4F"/>
-          </a:solidFill>
-          <a:ln/>
-        </p:spPr>
-      </p:sp>
-      <p:sp>
-        <p:nvSpPr>
-          <p:cNvPr id="24" name="Text 21"/>
-          <p:cNvSpPr/>
-          <p:nvPr/>
-        </p:nvSpPr>
-        <p:spPr>
-          <a:xfrm>
-            <a:off x="5074920" y="4773168"/>
-            <a:ext cx="4023360" cy="804672"/>
+          <p:cNvPr id="25" name="Text 22"/>
+          <p:cNvSpPr/>
+          <p:nvPr/>
+        </p:nvSpPr>
+        <p:spPr>
+          <a:xfrm>
+            <a:off x="8476488" y="3282696"/>
+            <a:ext cx="749808" cy="219456"/>
+          </a:xfrm>
+          <a:prstGeom prst="rect">
+            <a:avLst/>
+          </a:prstGeom>
+          <a:noFill/>
+          <a:ln/>
+        </p:spPr>
+        <p:txBody>
+          <a:bodyPr wrap="square" lIns="0" tIns="0" rIns="0" bIns="0" rtlCol="0" anchor="ctr"/>
+          <a:lstStyle/>
+          <a:p>
+            <a:pPr algn="ctr" indent="0" marL="0">
+              <a:buNone/>
+            </a:pPr>
+            <a:r>
+              <a:rPr lang="en-US" sz="1100" b="1" spc="200" kern="0" dirty="0">
+                <a:solidFill>
+                  <a:srgbClr val="0E5A52"/>
+                </a:solidFill>
+                <a:latin typeface="Manrope" pitchFamily="34" charset="0"/>
+                <a:ea typeface="Manrope" pitchFamily="34" charset="-122"/>
+                <a:cs typeface="Manrope" pitchFamily="34" charset="-120"/>
+              </a:rPr>
+              <a:t>FRI</a:t>
+            </a:r>
+            <a:endParaRPr lang="en-US" sz="1100" dirty="0"/>
+          </a:p>
+        </p:txBody>
+      </p:sp>
+      <p:sp>
+        <p:nvSpPr>
+          <p:cNvPr id="26" name="Text 23"/>
+          <p:cNvSpPr/>
+          <p:nvPr/>
+        </p:nvSpPr>
+        <p:spPr>
+          <a:xfrm>
+            <a:off x="8476488" y="3474720"/>
+            <a:ext cx="749808" cy="512064"/>
+          </a:xfrm>
+          <a:prstGeom prst="rect">
+            <a:avLst/>
+          </a:prstGeom>
+          <a:noFill/>
+          <a:ln/>
+        </p:spPr>
+        <p:txBody>
+          <a:bodyPr wrap="square" lIns="0" tIns="0" rIns="0" bIns="0" rtlCol="0" anchor="ctr"/>
+          <a:lstStyle/>
+          <a:p>
+            <a:pPr algn="ctr" indent="0" marL="0">
+              <a:buNone/>
+            </a:pPr>
+            <a:r>
+              <a:rPr lang="en-US" sz="3000" b="1" dirty="0">
+                <a:solidFill>
+                  <a:srgbClr val="10201C"/>
+                </a:solidFill>
+                <a:latin typeface="Manrope" pitchFamily="34" charset="0"/>
+                <a:ea typeface="Manrope" pitchFamily="34" charset="-122"/>
+                <a:cs typeface="Manrope" pitchFamily="34" charset="-120"/>
+              </a:rPr>
+              <a:t>23</a:t>
+            </a:r>
+            <a:endParaRPr lang="en-US" sz="3000" dirty="0"/>
+          </a:p>
+        </p:txBody>
+      </p:sp>
+      <p:sp>
+        <p:nvSpPr>
+          <p:cNvPr id="27" name="Text 24"/>
+          <p:cNvSpPr/>
+          <p:nvPr/>
+        </p:nvSpPr>
+        <p:spPr>
+          <a:xfrm>
+            <a:off x="9436608" y="3218688"/>
+            <a:ext cx="1810512" cy="201168"/>
           </a:xfrm>
           <a:prstGeom prst="rect">
             <a:avLst/>
@@ -6084,6 +6208,45 @@
               <a:buNone/>
             </a:pPr>
             <a:r>
+              <a:rPr lang="en-US" sz="1000" b="1" spc="250" kern="0" dirty="0">
+                <a:solidFill>
+                  <a:srgbClr val="6B7C77"/>
+                </a:solidFill>
+                <a:latin typeface="Manrope" pitchFamily="34" charset="0"/>
+                <a:ea typeface="Manrope" pitchFamily="34" charset="-122"/>
+                <a:cs typeface="Manrope" pitchFamily="34" charset="-120"/>
+              </a:rPr>
+              <a:t>EVENT</a:t>
+            </a:r>
+            <a:endParaRPr lang="en-US" sz="1000" dirty="0"/>
+          </a:p>
+        </p:txBody>
+      </p:sp>
+      <p:sp>
+        <p:nvSpPr>
+          <p:cNvPr id="28" name="Text 25"/>
+          <p:cNvSpPr/>
+          <p:nvPr/>
+        </p:nvSpPr>
+        <p:spPr>
+          <a:xfrm>
+            <a:off x="9436608" y="3447288"/>
+            <a:ext cx="1810512" cy="329184"/>
+          </a:xfrm>
+          <a:prstGeom prst="rect">
+            <a:avLst/>
+          </a:prstGeom>
+          <a:noFill/>
+          <a:ln/>
+        </p:spPr>
+        <p:txBody>
+          <a:bodyPr wrap="square" lIns="0" tIns="0" rIns="0" bIns="0" rtlCol="0" anchor="ctr"/>
+          <a:lstStyle/>
+          <a:p>
+            <a:pPr indent="0" marL="0">
+              <a:buNone/>
+            </a:pPr>
+            <a:r>
               <a:rPr lang="en-US" sz="1700" b="1" dirty="0">
                 <a:solidFill>
                   <a:srgbClr val="10201C"/>
@@ -6092,7 +6255,7 @@
                 <a:ea typeface="Manrope" pitchFamily="34" charset="-122"/>
                 <a:cs typeface="Manrope" pitchFamily="34" charset="-120"/>
               </a:rPr>
-              <a:t>Lunch with client · Fri 12:00 PM</a:t>
+              <a:t>Lunch with client</a:t>
             </a:r>
             <a:endParaRPr lang="en-US" sz="1700" dirty="0"/>
           </a:p>
@@ -6100,14 +6263,53 @@
       </p:sp>
       <p:sp>
         <p:nvSpPr>
-          <p:cNvPr id="25" name="Shape 22"/>
-          <p:cNvSpPr/>
-          <p:nvPr/>
-        </p:nvSpPr>
-        <p:spPr>
-          <a:xfrm>
-            <a:off x="9235440" y="4937760"/>
-            <a:ext cx="2011680" cy="475488"/>
+          <p:cNvPr id="29" name="Text 26"/>
+          <p:cNvSpPr/>
+          <p:nvPr/>
+        </p:nvSpPr>
+        <p:spPr>
+          <a:xfrm>
+            <a:off x="9436608" y="3776472"/>
+            <a:ext cx="1810512" cy="274320"/>
+          </a:xfrm>
+          <a:prstGeom prst="rect">
+            <a:avLst/>
+          </a:prstGeom>
+          <a:noFill/>
+          <a:ln/>
+        </p:spPr>
+        <p:txBody>
+          <a:bodyPr wrap="square" lIns="0" tIns="0" rIns="0" bIns="0" rtlCol="0" anchor="ctr"/>
+          <a:lstStyle/>
+          <a:p>
+            <a:pPr indent="0" marL="0">
+              <a:buNone/>
+            </a:pPr>
+            <a:r>
+              <a:rPr lang="en-US" sz="1500" dirty="0">
+                <a:solidFill>
+                  <a:srgbClr val="3E504B"/>
+                </a:solidFill>
+                <a:latin typeface="Manrope" pitchFamily="34" charset="0"/>
+                <a:ea typeface="Manrope" pitchFamily="34" charset="-122"/>
+                <a:cs typeface="Manrope" pitchFamily="34" charset="-120"/>
+              </a:rPr>
+              <a:t>12:00 PM</a:t>
+            </a:r>
+            <a:endParaRPr lang="en-US" sz="1500" dirty="0"/>
+          </a:p>
+        </p:txBody>
+      </p:sp>
+      <p:sp>
+        <p:nvSpPr>
+          <p:cNvPr id="30" name="Shape 27"/>
+          <p:cNvSpPr/>
+          <p:nvPr/>
+        </p:nvSpPr>
+        <p:spPr>
+          <a:xfrm>
+            <a:off x="8476488" y="4251960"/>
+            <a:ext cx="2011680" cy="329184"/>
           </a:xfrm>
           <a:prstGeom prst="roundRect">
             <a:avLst>
@@ -6115,26 +6317,21 @@
             </a:avLst>
           </a:prstGeom>
           <a:solidFill>
-            <a:srgbClr val="0F5A4F"/>
+            <a:srgbClr val="E1F4EA"/>
           </a:solidFill>
-          <a:ln w="12700">
-            <a:solidFill>
-              <a:srgbClr val="0F5A4F"/>
-            </a:solidFill>
-            <a:prstDash val="solid"/>
-          </a:ln>
-        </p:spPr>
-      </p:sp>
-      <p:sp>
-        <p:nvSpPr>
-          <p:cNvPr id="26" name="Text 23"/>
-          <p:cNvSpPr/>
-          <p:nvPr/>
-        </p:nvSpPr>
-        <p:spPr>
-          <a:xfrm>
-            <a:off x="9418320" y="4937760"/>
-            <a:ext cx="1645920" cy="475488"/>
+          <a:ln/>
+        </p:spPr>
+      </p:sp>
+      <p:sp>
+        <p:nvSpPr>
+          <p:cNvPr id="31" name="Text 28"/>
+          <p:cNvSpPr/>
+          <p:nvPr/>
+        </p:nvSpPr>
+        <p:spPr>
+          <a:xfrm>
+            <a:off x="8476488" y="4251960"/>
+            <a:ext cx="2011680" cy="329184"/>
           </a:xfrm>
           <a:prstGeom prst="rect">
             <a:avLst/>
@@ -6150,7 +6347,68 @@
               <a:buNone/>
             </a:pPr>
             <a:r>
-              <a:rPr lang="en-US" sz="1400" b="1" dirty="0">
+              <a:rPr lang="en-US" sz="1200" b="1" dirty="0">
+                <a:solidFill>
+                  <a:srgbClr val="177245"/>
+                </a:solidFill>
+                <a:latin typeface="Manrope" pitchFamily="34" charset="0"/>
+                <a:ea typeface="Manrope" pitchFamily="34" charset="-122"/>
+                <a:cs typeface="Manrope" pitchFamily="34" charset="-120"/>
+              </a:rPr>
+              <a:t>✓  Free · no conflicts</a:t>
+            </a:r>
+            <a:endParaRPr lang="en-US" sz="1200" dirty="0"/>
+          </a:p>
+        </p:txBody>
+      </p:sp>
+      <p:sp>
+        <p:nvSpPr>
+          <p:cNvPr id="32" name="Shape 29"/>
+          <p:cNvSpPr/>
+          <p:nvPr/>
+        </p:nvSpPr>
+        <p:spPr>
+          <a:xfrm>
+            <a:off x="8476488" y="4846320"/>
+            <a:ext cx="2706624" cy="512064"/>
+          </a:xfrm>
+          <a:prstGeom prst="roundRect">
+            <a:avLst>
+              <a:gd name="adj" fmla="val 50000"/>
+            </a:avLst>
+          </a:prstGeom>
+          <a:solidFill>
+            <a:srgbClr val="0E5A52"/>
+          </a:solidFill>
+          <a:ln/>
+        </p:spPr>
+      </p:sp>
+      <p:sp>
+        <p:nvSpPr>
+          <p:cNvPr id="33" name="Text 30"/>
+          <p:cNvSpPr/>
+          <p:nvPr/>
+        </p:nvSpPr>
+        <p:spPr>
+          <a:xfrm>
+            <a:off x="8476488" y="4846320"/>
+            <a:ext cx="2706624" cy="512064"/>
+          </a:xfrm>
+          <a:prstGeom prst="rect">
+            <a:avLst/>
+          </a:prstGeom>
+          <a:noFill/>
+          <a:ln/>
+        </p:spPr>
+        <p:txBody>
+          <a:bodyPr wrap="square" lIns="0" tIns="0" rIns="0" bIns="0" rtlCol="0" anchor="ctr"/>
+          <a:lstStyle/>
+          <a:p>
+            <a:pPr algn="ctr" indent="0" marL="0">
+              <a:buNone/>
+            </a:pPr>
+            <a:r>
+              <a:rPr lang="en-US" sz="1500" b="1" dirty="0">
                 <a:solidFill>
                   <a:srgbClr val="FFFFFF"/>
                 </a:solidFill>
@@ -6160,19 +6418,19 @@
               </a:rPr>
               <a:t>Add to calendar</a:t>
             </a:r>
-            <a:endParaRPr lang="en-US" sz="1400" dirty="0"/>
-          </a:p>
-        </p:txBody>
-      </p:sp>
-      <p:sp>
-        <p:nvSpPr>
-          <p:cNvPr id="27" name="Text 24"/>
-          <p:cNvSpPr/>
-          <p:nvPr/>
-        </p:nvSpPr>
-        <p:spPr>
-          <a:xfrm>
-            <a:off x="4206240" y="5760720"/>
+            <a:endParaRPr lang="en-US" sz="1500" dirty="0"/>
+          </a:p>
+        </p:txBody>
+      </p:sp>
+      <p:sp>
+        <p:nvSpPr>
+          <p:cNvPr id="34" name="Text 31"/>
+          <p:cNvSpPr/>
+          <p:nvPr/>
+        </p:nvSpPr>
+        <p:spPr>
+          <a:xfrm>
+            <a:off x="4206240" y="5870448"/>
             <a:ext cx="7269480" cy="411480"/>
           </a:xfrm>
           <a:prstGeom prst="rect">

</xml_diff>